<commit_message>
Revisão dos insights: números conferidos com as fontes
- Preços: frase que comparava litros de diesel com preço do GNV agora mostra o
  valor calculado (R$ 6,12 por m³ em GO × GNV mais caro do país no mês)
- Goiás: maiores potenciais sucroenergéticos são Goiatuba, Edéia, Mineiros e Caçu
- Pecuária do estudo (402 mi m³/ano) identificada como dado de 2023; ordem dos
  rebanhos de GO calculada a partir dos dados
- Utilização de 38,7% descrita como do parque de usinas, não da usina média
- Projeção de 3.391 mil m³/d condicionada à entrada dos pedidos em análise
- Goiás não produz biometano (o agregado 'Outros' do boletim é SC)
- Nome da aba Oportunidades atualizado; capturas, relatório, slides e notebook
</commit_message>
<xml_diff>
--- a/apresentacao/apresentacao_oral.pptx
+++ b/apresentacao/apresentacao_oral.pptx
@@ -3721,7 +3721,7 @@
                   <a:srgbClr val="057A64"/>
                 </a:solidFill>
               </a:rPr>
-              <a:t>GNC (caminhão) viabiliza usinas longe de gasodutos — como no interior de Goiás. Argumento de EVTE: cada m³ vendido carrega dois fluxos — energia + carbono.</a:t>
+              <a:t>GNC (caminhão) viabiliza usinas longe de gasodutos — como no interior de Goiás. Argumento de EVTE: cada m³ vendido por usina certificada carrega dois fluxos — energia + carbono.</a:t>
             </a:r>
           </a:p>
         </p:txBody>
@@ -3916,7 +3916,7 @@
                   <a:srgbClr val="2A0720"/>
                 </a:solidFill>
               </a:rPr>
-              <a:t>•  UTB Franca (SP): biometano a partir de resíduo de curtume — licença emitida, obra avançada</a:t>
+              <a:t>•  UTB Franca (SP): biometano a partir de resíduo de curtume — obras em estágio avançado, licença ambiental emitida</a:t>
             </a:r>
           </a:p>
           <a:p>
@@ -3969,7 +3969,7 @@
                   <a:srgbClr val="057A64"/>
                 </a:solidFill>
               </a:rPr>
-              <a:t>Cobre os três estágios do ciclo (operação → construção → escala) e o mix de substratos minoritário no mercado nacional (~20% da produção fora de aterros).</a:t>
+              <a:t>Cobre os três estágios do ciclo (operação → construção → projeto industrial em operação) e o mix de substratos minoritário no mercado nacional (~20% da produção fora de aterros).</a:t>
             </a:r>
           </a:p>
         </p:txBody>
@@ -4229,7 +4229,7 @@
                   <a:srgbClr val="2A0720"/>
                 </a:solidFill>
               </a:rPr>
-              <a:t>Funcionamento: aba Goiás &amp; Oportunidades</a:t>
+              <a:t>Funcionamento: aba Oportunidades (Goiás em detalhe)</a:t>
             </a:r>
           </a:p>
           <a:p>
@@ -5278,7 +5278,7 @@
                   <a:srgbClr val="2A0720"/>
                 </a:solidFill>
               </a:rPr>
-              <a:t>1. Priorizar Goiás: RSU em Goiânia (vitrine CEASA), pecuária dispersa (Rio Verde, Jataí) e parcerias sucroenergéticas no sul goiano</a:t>
+              <a:t>1. Priorizar Goiás: RSU em Goiânia (vitrine CEASA), pecuária dispersa (Rio Verde, Jataí) e parcerias sucroenergéticas no sul e sudoeste goianos</a:t>
             </a:r>
           </a:p>
           <a:p>
@@ -5293,7 +5293,7 @@
                   <a:srgbClr val="2A0720"/>
                 </a:solidFill>
               </a:rPr>
-              <a:t>2. Oferecer O&amp;M e otimização: a usina média opera a 38,7% da capacidade autorizada</a:t>
+              <a:t>2. Oferecer O&amp;M e otimização: o parque opera a 38,7% da capacidade autorizada</a:t>
             </a:r>
           </a:p>
           <a:p>
@@ -8477,7 +8477,7 @@
                   <a:srgbClr val="2A0720"/>
                 </a:solidFill>
               </a:rPr>
-              <a:t>•  Sucroenergético (Goiatuba, Edéia, Mineiros, Itumbiara) → frente de maior escala, via parcerias</a:t>
+              <a:t>•  Sucroenergético (Goiatuba, Edéia, Mineiros, Caçu) → frente de maior escala, via parcerias</a:t>
             </a:r>
           </a:p>
           <a:p>
@@ -8507,7 +8507,7 @@
                   <a:srgbClr val="2A0720"/>
                 </a:solidFill>
               </a:rPr>
-              <a:t>•  Sem mercado de GNV em GO: 1 m³ de biometano substitui ≈ R$ 6,12 em diesel — acima do GNV de qualquer estado</a:t>
+              <a:t>•  Sem mercado de GNV em GO: 1 m³ de biometano substitui ≈ R$ 6,12 em diesel — acima do GNV de qualquer estado (set/26)</a:t>
             </a:r>
           </a:p>
         </p:txBody>

</xml_diff>

<commit_message>
Revisão geral: mapa, visual, relatório e slides
- Mapa: estados com usina mas sem produção no mês (MG, PR, MS) não aparecem mais
  como 'sem usina autorizada'; legenda da cor ajustada ao tema escuro
- Insight da Visão Geral passa a seguir o filtro de fontes
- Abas com nomes curtos (cabem na tela); rótulo da rosca não é mais cortado;
  capacidade das usinas com vírgula decimal
- Barra lateral lista todas as fontes selecionadas; KPI de Goiás identificado
  como potencial de biometano
- Relatório: unidade do CSV da ANP corrigida, visualizações do IBGE e de preços,
  Anuário da ANP nas referências
- Slides: KPIs do IBGE e de preços, título do slide 13, slide final atualizado
- Link do IBGE trocado pelo das tabelas 3939 e 94 (o anterior recusava acesso)
- Nome de usina com erro de digitação da ANP corrigido na leitura
</commit_message>
<xml_diff>
--- a/apresentacao/apresentacao_oral.pptx
+++ b/apresentacao/apresentacao_oral.pptx
@@ -4229,7 +4229,7 @@
                   <a:srgbClr val="2A0720"/>
                 </a:solidFill>
               </a:rPr>
-              <a:t>Funcionamento: aba Oportunidades (Goiás em detalhe)</a:t>
+              <a:t>Funcionamento: Goiás em detalhe</a:t>
             </a:r>
           </a:p>
           <a:p>
@@ -4443,7 +4443,7 @@
         </p:nvGraphicFramePr>
         <p:xfrm>
           <a:off x="640080" y="1554480"/>
-          <a:ext cx="10972800" cy="2304288"/>
+          <a:ext cx="10972800" cy="2688336"/>
         </p:xfrm>
         <a:graphic>
           <a:graphicData uri="http://schemas.openxmlformats.org/drawingml/2006/table">
@@ -4640,7 +4640,7 @@
                             <a:srgbClr val="2A0720"/>
                           </a:solidFill>
                         </a:rPr>
-                        <a:t>Leitura territorial; sem dado ≠ valor baixo (cinza)</a:t>
+                        <a:t>Leitura territorial; sem dado ≠ valor baixo (bege)</a:t>
                       </a:r>
                     </a:p>
                   </a:txBody>
@@ -4846,6 +4846,71 @@
                   </a:tcPr>
                 </a:tc>
               </a:tr>
+              <a:tr h="384048">
+                <a:tc>
+                  <a:txBody>
+                    <a:bodyPr/>
+                    <a:lstStyle/>
+                    <a:p>
+                      <a:r>
+                        <a:rPr sz="1400" b="0">
+                          <a:solidFill>
+                            <a:srgbClr val="2A0720"/>
+                          </a:solidFill>
+                        </a:rPr>
+                        <a:t>Quanto vale o biometano?</a:t>
+                      </a:r>
+                    </a:p>
+                  </a:txBody>
+                  <a:tcPr>
+                    <a:solidFill>
+                      <a:srgbClr val="FFFFFF"/>
+                    </a:solidFill>
+                  </a:tcPr>
+                </a:tc>
+                <a:tc>
+                  <a:txBody>
+                    <a:bodyPr/>
+                    <a:lstStyle/>
+                    <a:p>
+                      <a:r>
+                        <a:rPr sz="1400" b="0">
+                          <a:solidFill>
+                            <a:srgbClr val="2A0720"/>
+                          </a:solidFill>
+                        </a:rPr>
+                        <a:t>Linhas diesel × GNV</a:t>
+                      </a:r>
+                    </a:p>
+                  </a:txBody>
+                  <a:tcPr>
+                    <a:solidFill>
+                      <a:srgbClr val="FFFFFF"/>
+                    </a:solidFill>
+                  </a:tcPr>
+                </a:tc>
+                <a:tc>
+                  <a:txBody>
+                    <a:bodyPr/>
+                    <a:lstStyle/>
+                    <a:p>
+                      <a:r>
+                        <a:rPr sz="1400" b="0">
+                          <a:solidFill>
+                            <a:srgbClr val="2A0720"/>
+                          </a:solidFill>
+                        </a:rPr>
+                        <a:t>Mesma base de comparação (R$/m³ eq.)</a:t>
+                      </a:r>
+                    </a:p>
+                  </a:txBody>
+                  <a:tcPr>
+                    <a:solidFill>
+                      <a:srgbClr val="FFFFFF"/>
+                    </a:solidFill>
+                  </a:tcPr>
+                </a:tc>
+              </a:tr>
             </a:tbl>
           </a:graphicData>
         </a:graphic>
@@ -4858,8 +4923,8 @@
         </p:nvSpPr>
         <p:spPr>
           <a:xfrm>
-            <a:off x="640080" y="4206240"/>
-            <a:ext cx="10972800" cy="2286000"/>
+            <a:off x="640080" y="4754880"/>
+            <a:ext cx="10972800" cy="1737360"/>
           </a:xfrm>
           <a:prstGeom prst="rect">
             <a:avLst/>
@@ -5338,7 +5403,7 @@
                   <a:srgbClr val="6E6470"/>
                 </a:solidFill>
               </a:rPr>
-              <a:t>Evoluções: pipeline comercial interno, preços de substituição e atualização automática</a:t>
+              <a:t>Evoluções: pipeline comercial interno, preços de GLP/gás industrial/energia e atualização automática</a:t>
             </a:r>
           </a:p>
         </p:txBody>
@@ -5740,7 +5805,7 @@
                   <a:srgbClr val="C9B8C6"/>
                 </a:solidFill>
               </a:rPr>
-              <a:t>Painel: app/app.py · Relatório: relatorio/ · Dados: IEPUC-PUC-Rio (ago/2026) e Governo de Goiás (2026)</a:t>
+              <a:t>Código: github.com/NathanC16/Radar-Econ-mico-do-Biometano · Dados públicos: IEPUC-PUC-Rio, ANP, IBGE, Governo de Goiás e site da 4WaTT</a:t>
             </a:r>
           </a:p>
         </p:txBody>
@@ -6887,7 +6952,7 @@
         </p:nvGraphicFramePr>
         <p:xfrm>
           <a:off x="640080" y="1554480"/>
-          <a:ext cx="10972800" cy="3072384"/>
+          <a:ext cx="10972800" cy="3840480"/>
         </p:xfrm>
         <a:graphic>
           <a:graphicData uri="http://schemas.openxmlformats.org/drawingml/2006/table">
@@ -6906,7 +6971,7 @@
                     <a:lstStyle/>
                     <a:p>
                       <a:r>
-                        <a:rPr sz="1500" b="1">
+                        <a:rPr sz="1400" b="1">
                           <a:solidFill>
                             <a:srgbClr val="FFFFFF"/>
                           </a:solidFill>
@@ -6927,7 +6992,7 @@
                     <a:lstStyle/>
                     <a:p>
                       <a:r>
-                        <a:rPr sz="1500" b="1">
+                        <a:rPr sz="1400" b="1">
                           <a:solidFill>
                             <a:srgbClr val="FFFFFF"/>
                           </a:solidFill>
@@ -6950,7 +7015,7 @@
                     <a:lstStyle/>
                     <a:p>
                       <a:r>
-                        <a:rPr sz="1500" b="0">
+                        <a:rPr sz="1400" b="0">
                           <a:solidFill>
                             <a:srgbClr val="2A0720"/>
                           </a:solidFill>
@@ -6971,7 +7036,7 @@
                     <a:lstStyle/>
                     <a:p>
                       <a:r>
-                        <a:rPr sz="1500" b="0">
+                        <a:rPr sz="1400" b="0">
                           <a:solidFill>
                             <a:srgbClr val="2A0720"/>
                           </a:solidFill>
@@ -6994,7 +7059,7 @@
                     <a:lstStyle/>
                     <a:p>
                       <a:r>
-                        <a:rPr sz="1500" b="0">
+                        <a:rPr sz="1400" b="0">
                           <a:solidFill>
                             <a:srgbClr val="2A0720"/>
                           </a:solidFill>
@@ -7015,7 +7080,7 @@
                     <a:lstStyle/>
                     <a:p>
                       <a:r>
-                        <a:rPr sz="1500" b="0">
+                        <a:rPr sz="1400" b="0">
                           <a:solidFill>
                             <a:srgbClr val="2A0720"/>
                           </a:solidFill>
@@ -7038,7 +7103,7 @@
                     <a:lstStyle/>
                     <a:p>
                       <a:r>
-                        <a:rPr sz="1500" b="0">
+                        <a:rPr sz="1400" b="0">
                           <a:solidFill>
                             <a:srgbClr val="2A0720"/>
                           </a:solidFill>
@@ -7059,7 +7124,7 @@
                     <a:lstStyle/>
                     <a:p>
                       <a:r>
-                        <a:rPr sz="1500" b="0">
+                        <a:rPr sz="1400" b="0">
                           <a:solidFill>
                             <a:srgbClr val="2A0720"/>
                           </a:solidFill>
@@ -7082,7 +7147,7 @@
                     <a:lstStyle/>
                     <a:p>
                       <a:r>
-                        <a:rPr sz="1500" b="0">
+                        <a:rPr sz="1400" b="0">
                           <a:solidFill>
                             <a:srgbClr val="2A0720"/>
                           </a:solidFill>
@@ -7103,7 +7168,7 @@
                     <a:lstStyle/>
                     <a:p>
                       <a:r>
-                        <a:rPr sz="1500" b="0">
+                        <a:rPr sz="1400" b="0">
                           <a:solidFill>
                             <a:srgbClr val="2A0720"/>
                           </a:solidFill>
@@ -7126,7 +7191,7 @@
                     <a:lstStyle/>
                     <a:p>
                       <a:r>
-                        <a:rPr sz="1500" b="0">
+                        <a:rPr sz="1400" b="0">
                           <a:solidFill>
                             <a:srgbClr val="2A0720"/>
                           </a:solidFill>
@@ -7147,7 +7212,7 @@
                     <a:lstStyle/>
                     <a:p>
                       <a:r>
-                        <a:rPr sz="1500" b="0">
+                        <a:rPr sz="1400" b="0">
                           <a:solidFill>
                             <a:srgbClr val="2A0720"/>
                           </a:solidFill>
@@ -7170,7 +7235,7 @@
                     <a:lstStyle/>
                     <a:p>
                       <a:r>
-                        <a:rPr sz="1500" b="0">
+                        <a:rPr sz="1400" b="0">
                           <a:solidFill>
                             <a:srgbClr val="2A0720"/>
                           </a:solidFill>
@@ -7191,7 +7256,7 @@
                     <a:lstStyle/>
                     <a:p>
                       <a:r>
-                        <a:rPr sz="1500" b="0">
+                        <a:rPr sz="1400" b="0">
                           <a:solidFill>
                             <a:srgbClr val="2A0720"/>
                           </a:solidFill>
@@ -7214,7 +7279,95 @@
                     <a:lstStyle/>
                     <a:p>
                       <a:r>
-                        <a:rPr sz="1500" b="0">
+                        <a:rPr sz="1400" b="0">
+                          <a:solidFill>
+                            <a:srgbClr val="2A0720"/>
+                          </a:solidFill>
+                        </a:rPr>
+                        <a:t>Potencial da pecuária por estado (IBGE)</a:t>
+                      </a:r>
+                    </a:p>
+                  </a:txBody>
+                  <a:tcPr>
+                    <a:solidFill>
+                      <a:srgbClr val="F4F1EB"/>
+                    </a:solidFill>
+                  </a:tcPr>
+                </a:tc>
+                <a:tc>
+                  <a:txBody>
+                    <a:bodyPr/>
+                    <a:lstStyle/>
+                    <a:p>
+                      <a:r>
+                        <a:rPr sz="1400" b="0">
+                          <a:solidFill>
+                            <a:srgbClr val="2A0720"/>
+                          </a:solidFill>
+                        </a:rPr>
+                        <a:t>Goiás frente ao país: onde estão os dejetos</a:t>
+                      </a:r>
+                    </a:p>
+                  </a:txBody>
+                  <a:tcPr>
+                    <a:solidFill>
+                      <a:srgbClr val="F4F1EB"/>
+                    </a:solidFill>
+                  </a:tcPr>
+                </a:tc>
+              </a:tr>
+              <a:tr h="384048">
+                <a:tc>
+                  <a:txBody>
+                    <a:bodyPr/>
+                    <a:lstStyle/>
+                    <a:p>
+                      <a:r>
+                        <a:rPr sz="1400" b="0">
+                          <a:solidFill>
+                            <a:srgbClr val="2A0720"/>
+                          </a:solidFill>
+                        </a:rPr>
+                        <a:t>Diesel × GNV por estado (ANP, R$/m³ eq.)</a:t>
+                      </a:r>
+                    </a:p>
+                  </a:txBody>
+                  <a:tcPr>
+                    <a:solidFill>
+                      <a:srgbClr val="FFFFFF"/>
+                    </a:solidFill>
+                  </a:tcPr>
+                </a:tc>
+                <a:tc>
+                  <a:txBody>
+                    <a:bodyPr/>
+                    <a:lstStyle/>
+                    <a:p>
+                      <a:r>
+                        <a:rPr sz="1400" b="0">
+                          <a:solidFill>
+                            <a:srgbClr val="2A0720"/>
+                          </a:solidFill>
+                        </a:rPr>
+                        <a:t>Quanto o cliente economiza ao trocar de combustível</a:t>
+                      </a:r>
+                    </a:p>
+                  </a:txBody>
+                  <a:tcPr>
+                    <a:solidFill>
+                      <a:srgbClr val="FFFFFF"/>
+                    </a:solidFill>
+                  </a:tcPr>
+                </a:tc>
+              </a:tr>
+              <a:tr h="384048">
+                <a:tc>
+                  <a:txBody>
+                    <a:bodyPr/>
+                    <a:lstStyle/>
+                    <a:p>
+                      <a:r>
+                        <a:rPr sz="1400" b="0">
                           <a:solidFill>
                             <a:srgbClr val="2A0720"/>
                           </a:solidFill>
@@ -7235,7 +7388,7 @@
                     <a:lstStyle/>
                     <a:p>
                       <a:r>
-                        <a:rPr sz="1500" b="0">
+                        <a:rPr sz="1400" b="0">
                           <a:solidFill>
                             <a:srgbClr val="2A0720"/>
                           </a:solidFill>

</xml_diff>

<commit_message>
Nova fonte: CIBiogás (plantas de biogás por estado e no Brasil, Panoramas 2023–2025)
</commit_message>
<xml_diff>
--- a/apresentacao/apresentacao_oral.pptx
+++ b/apresentacao/apresentacao_oral.pptx
@@ -5805,7 +5805,7 @@
                   <a:srgbClr val="C9B8C6"/>
                 </a:solidFill>
               </a:rPr>
-              <a:t>Código: github.com/NathanC16/Radar-Econ-mico-do-Biometano · Dados públicos: IEPUC-PUC-Rio, ANP, IBGE, Governo de Goiás e site da 4WaTT</a:t>
+              <a:t>Código: github.com/NathanC16/Radar-Econ-mico-do-Biometano · Dados públicos: IEPUC-PUC-Rio, ANP, IBGE, CIBiogás, Governo de Goiás e site da 4WaTT</a:t>
             </a:r>
           </a:p>
         </p:txBody>
@@ -6735,7 +6735,7 @@
                   <a:srgbClr val="2A0720"/>
                 </a:solidFill>
               </a:rPr>
-              <a:t>Fontes: Boletim IEPUC-PUC-Rio ago/2026 (ANP · MME · B3) · dados abertos da ANP (produção, usinas e preços de combustíveis) · IBGE (rebanhos) · Panorama do Biometano em Goiás · site da 4WaTT</a:t>
+              <a:t>Fontes: Boletim IEPUC-PUC-Rio ago/2026 (ANP · MME · B3) · dados abertos da ANP (produção, usinas e preços de combustíveis) · IBGE (rebanhos) · CIBiogás (plantas de biogás) · Panorama do Biometano em Goiás · site da 4WaTT</a:t>
             </a:r>
           </a:p>
           <a:p>
@@ -6765,7 +6765,7 @@
                   <a:srgbClr val="2A0720"/>
                 </a:solidFill>
               </a:rPr>
-              <a:t>Pandas → 16 bases (CSV)   |   Plotly → gráficos interativos   |   Streamlit → painel com 7 abas, filtros e tema escuro</a:t>
+              <a:t>Pandas → 18 bases (CSV)   |   Plotly → gráficos interativos   |   Streamlit → painel com 7 abas, filtros e tema escuro</a:t>
             </a:r>
           </a:p>
           <a:p>
@@ -6780,7 +6780,7 @@
                   <a:srgbClr val="2A0720"/>
                 </a:solidFill>
               </a:rPr>
-              <a:t>Qualidade: 83 verificações automatizadas — busca de cada valor no texto dos PDFs e validação cruzada IEPUC × dados abertos da ANP (diferença &lt; 0,5 mil m³/d em 2026)</a:t>
+              <a:t>Qualidade: 91 verificações automatizadas — busca de cada valor no texto dos PDFs e validação cruzada IEPUC × dados abertos da ANP (diferença &lt; 0,5 mil m³/d em 2026)</a:t>
             </a:r>
           </a:p>
           <a:p>
@@ -6952,7 +6952,7 @@
         </p:nvGraphicFramePr>
         <p:xfrm>
           <a:off x="640080" y="1554480"/>
-          <a:ext cx="10972800" cy="3840480"/>
+          <a:ext cx="10972800" cy="4224528"/>
         </p:xfrm>
         <a:graphic>
           <a:graphicData uri="http://schemas.openxmlformats.org/drawingml/2006/table">
@@ -7328,7 +7328,7 @@
                             <a:srgbClr val="2A0720"/>
                           </a:solidFill>
                         </a:rPr>
-                        <a:t>Diesel × GNV por estado (ANP, R$/m³ eq.)</a:t>
+                        <a:t>Plantas de biogás por estado (CIBiogás)</a:t>
                       </a:r>
                     </a:p>
                   </a:txBody>
@@ -7349,7 +7349,7 @@
                             <a:srgbClr val="2A0720"/>
                           </a:solidFill>
                         </a:rPr>
-                        <a:t>Quanto o cliente economiza ao trocar de combustível</a:t>
+                        <a:t>Base instalada que pode virar biometano</a:t>
                       </a:r>
                     </a:p>
                   </a:txBody>
@@ -7372,7 +7372,7 @@
                             <a:srgbClr val="2A0720"/>
                           </a:solidFill>
                         </a:rPr>
-                        <a:t>Potencial de biogás em Goiás (fonte × município)</a:t>
+                        <a:t>Diesel × GNV por estado (ANP, R$/m³ eq.)</a:t>
                       </a:r>
                     </a:p>
                   </a:txBody>
@@ -7393,13 +7393,57 @@
                             <a:srgbClr val="2A0720"/>
                           </a:solidFill>
                         </a:rPr>
+                        <a:t>Quanto o cliente economiza ao trocar de combustível</a:t>
+                      </a:r>
+                    </a:p>
+                  </a:txBody>
+                  <a:tcPr>
+                    <a:solidFill>
+                      <a:srgbClr val="F4F1EB"/>
+                    </a:solidFill>
+                  </a:tcPr>
+                </a:tc>
+              </a:tr>
+              <a:tr h="384048">
+                <a:tc>
+                  <a:txBody>
+                    <a:bodyPr/>
+                    <a:lstStyle/>
+                    <a:p>
+                      <a:r>
+                        <a:rPr sz="1400" b="0">
+                          <a:solidFill>
+                            <a:srgbClr val="2A0720"/>
+                          </a:solidFill>
+                        </a:rPr>
+                        <a:t>Potencial de biogás em Goiás (fonte × município)</a:t>
+                      </a:r>
+                    </a:p>
+                  </a:txBody>
+                  <a:tcPr>
+                    <a:solidFill>
+                      <a:srgbClr val="FFFFFF"/>
+                    </a:solidFill>
+                  </a:tcPr>
+                </a:tc>
+                <a:tc>
+                  <a:txBody>
+                    <a:bodyPr/>
+                    <a:lstStyle/>
+                    <a:p>
+                      <a:r>
+                        <a:rPr sz="1400" b="0">
+                          <a:solidFill>
+                            <a:srgbClr val="2A0720"/>
+                          </a:solidFill>
+                        </a:rPr>
                         <a:t>Priorização da prospecção no estado-sede</a:t>
                       </a:r>
                     </a:p>
                   </a:txBody>
                   <a:tcPr>
                     <a:solidFill>
-                      <a:srgbClr val="F4F1EB"/>
+                      <a:srgbClr val="FFFFFF"/>
                     </a:solidFill>
                   </a:tcPr>
                 </a:tc>
@@ -8645,7 +8689,7 @@
                   <a:srgbClr val="2A0720"/>
                 </a:solidFill>
               </a:rPr>
-              <a:t>•  Brasil (IBGE): GO é o 5º estado em potencial pecuário e o 2º em vacas ordenhadas</a:t>
+              <a:t>•  Brasil: GO é o 5º em plantas de biogás (131, CIBiogás 2025) e em potencial pecuário (IBGE) — e não produz biometano: conversão de plantas existentes</a:t>
             </a:r>
           </a:p>
           <a:p>

</xml_diff>

<commit_message>
Revisão geral: consistência dos números de Goiás, referências em ordem alfabética e metadados
- Painel: Goiás com 131 plantas de biogás (CIBiogás 2025) também na Visão Geral;
  ranking da CIBiogás ordenado explicitamente; data da fonte das 122 plantas unificada
- Relatório: busca literal inclui CIBiogás/ABEGÁS; Goiás sem produção de biometano
  (não 'quase nenhuma'); resultados citam os KPIs novos; referências em ordem alfabética
- Slides: recomendação de converter plantas de biogás existentes; supervisor nomeado;
  data de criação correta nos metadados; imports não usados removidos
- README: descrição dos dados brutos e da validação atualizada
</commit_message>
<xml_diff>
--- a/apresentacao/apresentacao_oral.pptx
+++ b/apresentacao/apresentacao_oral.pptx
@@ -5153,7 +5153,7 @@
                   <a:srgbClr val="2A0720"/>
                 </a:solidFill>
               </a:rPr>
-              <a:t>3. Leitura — Goiás &amp; Portfolio: o estado-sede tem potencial e quase nenhuma produção; o portfolio já atua nesse espaço</a:t>
+              <a:t>3. Leitura — Goiás &amp; Portfolio: o estado-sede tem potencial e nenhuma produção de biometano; o portfolio já atua nesse espaço</a:t>
             </a:r>
           </a:p>
           <a:p>
@@ -5358,7 +5358,7 @@
                   <a:srgbClr val="2A0720"/>
                 </a:solidFill>
               </a:rPr>
-              <a:t>2. Oferecer O&amp;M e otimização: o parque opera a 38,7% da capacidade autorizada</a:t>
+              <a:t>2. Converter em biometano as plantas de biogás que já existem: Goiás tem 131 (5º do país) e nenhuma usina ANP</a:t>
             </a:r>
           </a:p>
           <a:p>
@@ -5373,7 +5373,7 @@
                   <a:srgbClr val="2A0720"/>
                 </a:solidFill>
               </a:rPr>
-              <a:t>3. Usar os KPIs em EVTEs e com investidores: crescimento + CBio = tese de viabilidade robusta</a:t>
+              <a:t>3. Oferecer O&amp;M e otimização: o parque opera a 38,7% da capacidade autorizada</a:t>
             </a:r>
           </a:p>
           <a:p>
@@ -5388,7 +5388,22 @@
                   <a:srgbClr val="2A0720"/>
                 </a:solidFill>
               </a:rPr>
-              <a:t>4. Monitorar mensalmente o boletim IEPUC — o pipeline ANP é o termômetro da demanda por EPC/O&amp;M</a:t>
+              <a:t>4. Usar os KPIs em EVTEs e com investidores: crescimento + CBio = tese de viabilidade robusta</a:t>
+            </a:r>
+          </a:p>
+          <a:p>
+            <a:pPr>
+              <a:spcAft>
+                <a:spcPts val="1000"/>
+              </a:spcAft>
+            </a:pPr>
+            <a:r>
+              <a:rPr sz="1800" b="0">
+                <a:solidFill>
+                  <a:srgbClr val="2A0720"/>
+                </a:solidFill>
+              </a:rPr>
+              <a:t>5. Monitorar mensalmente o boletim IEPUC — o pipeline ANP é o termômetro da demanda por EPC/O&amp;M</a:t>
             </a:r>
           </a:p>
           <a:p>
@@ -6495,7 +6510,7 @@
                   <a:srgbClr val="2A0720"/>
                 </a:solidFill>
               </a:rPr>
-              <a:t>1.  Alinhamento do escopo com a equipe da 4WaTT: identificação do problema de inteligência de mercado</a:t>
+              <a:t>1.  Alinhamento do escopo com Brunno Bachmann, CTO da 4WaTT: identificação do problema de inteligência de mercado</a:t>
             </a:r>
           </a:p>
           <a:p>
@@ -8271,7 +8286,7 @@
                   <a:srgbClr val="2A0720"/>
                 </a:solidFill>
               </a:rPr>
-              <a:t>Goiás: muito potencial, quase nenhuma produção</a:t>
+              <a:t>Goiás: muito potencial, zero biometano</a:t>
             </a:r>
           </a:p>
           <a:p>

</xml_diff>